<commit_message>
Redesign consistency slide as chain + decision box layout
Replace dense table with λmax→CI→CR chain, CR acceptance panel,
n/RI badges, numeric example, and CR scale bar with sidebar.

Co-authored-by: sazmanfava854-sudo <sazmanfava854-sudo@users.noreply.github.com>
</commit_message>
<xml_diff>
--- a/presentations/بررسی_سازگاری_ماتریس_نهایی.pptx
+++ b/presentations/بررسی_سازگاری_ماتریس_نهایی.pptx
@@ -3103,7 +3103,7 @@
             <a:avLst/>
           </a:prstGeom>
           <a:solidFill>
-            <a:srgbClr val="F7F9FC"/>
+            <a:srgbClr val="FAFBFC"/>
           </a:solidFill>
           <a:ln>
             <a:noFill/>
@@ -3139,14 +3139,14 @@
         </p:nvSpPr>
         <p:spPr>
           <a:xfrm>
-            <a:off x="0" y="0"/>
-            <a:ext cx="9144000" cy="109728"/>
+            <a:off x="8641080" y="0"/>
+            <a:ext cx="502920" cy="5143500"/>
           </a:xfrm>
           <a:prstGeom prst="rect">
             <a:avLst/>
           </a:prstGeom>
           <a:solidFill>
-            <a:srgbClr val="1E3A5F"/>
+            <a:srgbClr val="2563EB"/>
           </a:solidFill>
           <a:ln>
             <a:noFill/>
@@ -3176,20 +3176,20 @@
       </p:sp>
       <p:sp>
         <p:nvSpPr>
-          <p:cNvPr id="4" name="Rectangle 3"/>
+          <p:cNvPr id="4" name="Oval 3"/>
           <p:cNvSpPr/>
           <p:nvPr/>
         </p:nvSpPr>
         <p:spPr>
           <a:xfrm>
-            <a:off x="320040" y="1051560"/>
-            <a:ext cx="73152" cy="685800"/>
-          </a:xfrm>
-          <a:prstGeom prst="rect">
+            <a:off x="8801100" y="731520"/>
+            <a:ext cx="182880" cy="182880"/>
+          </a:xfrm>
+          <a:prstGeom prst="ellipse">
             <a:avLst/>
           </a:prstGeom>
           <a:solidFill>
-            <a:srgbClr val="009688"/>
+            <a:srgbClr val="DBEAFE"/>
           </a:solidFill>
           <a:ln>
             <a:noFill/>
@@ -3219,90 +3219,20 @@
       </p:sp>
       <p:sp>
         <p:nvSpPr>
-          <p:cNvPr id="5" name="TextBox 4"/>
-          <p:cNvSpPr txBox="1"/>
-          <p:nvPr/>
-        </p:nvSpPr>
-        <p:spPr>
-          <a:xfrm>
-            <a:off x="502920" y="320040"/>
-            <a:ext cx="8046720" cy="594360"/>
-          </a:xfrm>
-          <a:prstGeom prst="rect">
-            <a:avLst/>
-          </a:prstGeom>
-          <a:noFill/>
-        </p:spPr>
-        <p:txBody>
-          <a:bodyPr wrap="square" anchor="ctr">
-            <a:spAutoFit/>
-          </a:bodyPr>
-          <a:lstStyle/>
-          <a:p>
-            <a:pPr algn="r" a:rtl="1"/>
-            <a:r>
-              <a:rPr sz="3000" b="1">
-                <a:solidFill>
-                  <a:srgbClr val="1E3A5F"/>
-                </a:solidFill>
-                <a:latin typeface="Tahoma"/>
-              </a:rPr>
-              <a:t>بررسی سازگاری ماتریس نهایی</a:t>
-            </a:r>
-          </a:p>
-        </p:txBody>
-      </p:sp>
-      <p:sp>
-        <p:nvSpPr>
-          <p:cNvPr id="6" name="TextBox 5"/>
-          <p:cNvSpPr txBox="1"/>
-          <p:nvPr/>
-        </p:nvSpPr>
-        <p:spPr>
-          <a:xfrm>
-            <a:off x="502920" y="868680"/>
-            <a:ext cx="8046720" cy="411480"/>
-          </a:xfrm>
-          <a:prstGeom prst="rect">
-            <a:avLst/>
-          </a:prstGeom>
-          <a:noFill/>
-        </p:spPr>
-        <p:txBody>
-          <a:bodyPr wrap="square" anchor="ctr">
-            <a:spAutoFit/>
-          </a:bodyPr>
-          <a:lstStyle/>
-          <a:p>
-            <a:pPr algn="r" a:rtl="1"/>
-            <a:r>
-              <a:rPr sz="1400" b="0">
-                <a:solidFill>
-                  <a:srgbClr val="6B7280"/>
-                </a:solidFill>
-                <a:latin typeface="Tahoma"/>
-              </a:rPr>
-              <a:t>پس از محاسبه بردار وزن، سازگاری ماتریس تجمیع‌شده بررسی می‌شود:</a:t>
-            </a:r>
-          </a:p>
-        </p:txBody>
-      </p:sp>
-      <p:sp>
-        <p:nvSpPr>
-          <p:cNvPr id="7" name="Rounded Rectangle 6"/>
+          <p:cNvPr id="5" name="Oval 4"/>
           <p:cNvSpPr/>
           <p:nvPr/>
         </p:nvSpPr>
         <p:spPr>
           <a:xfrm>
-            <a:off x="8183879" y="384048"/>
-            <a:ext cx="868680" cy="384048"/>
-          </a:xfrm>
-          <a:prstGeom prst="roundRect">
+            <a:off x="8801100" y="1463040"/>
+            <a:ext cx="182880" cy="182880"/>
+          </a:xfrm>
+          <a:prstGeom prst="ellipse">
             <a:avLst/>
           </a:prstGeom>
           <a:solidFill>
-            <a:srgbClr val="2B5C8A"/>
+            <a:srgbClr val="DBEAFE"/>
           </a:solidFill>
           <a:ln>
             <a:noFill/>
@@ -3327,729 +3257,1206 @@
           <a:lstStyle/>
           <a:p>
             <a:pPr algn="ctr"/>
-            <a:r>
-              <a:rPr sz="1300" b="1">
+          </a:p>
+        </p:txBody>
+      </p:sp>
+      <p:sp>
+        <p:nvSpPr>
+          <p:cNvPr id="6" name="Oval 5"/>
+          <p:cNvSpPr/>
+          <p:nvPr/>
+        </p:nvSpPr>
+        <p:spPr>
+          <a:xfrm>
+            <a:off x="8691372" y="2130552"/>
+            <a:ext cx="402336" cy="402336"/>
+          </a:xfrm>
+          <a:prstGeom prst="ellipse">
+            <a:avLst/>
+          </a:prstGeom>
+          <a:solidFill>
+            <a:srgbClr val="FFFFFF"/>
+          </a:solidFill>
+          <a:ln>
+            <a:noFill/>
+          </a:ln>
+        </p:spPr>
+        <p:style>
+          <a:lnRef idx="1">
+            <a:schemeClr val="accent1"/>
+          </a:lnRef>
+          <a:fillRef idx="3">
+            <a:schemeClr val="accent1"/>
+          </a:fillRef>
+          <a:effectRef idx="2">
+            <a:schemeClr val="accent1"/>
+          </a:effectRef>
+          <a:fontRef idx="minor">
+            <a:schemeClr val="lt1"/>
+          </a:fontRef>
+        </p:style>
+        <p:txBody>
+          <a:bodyPr rtlCol="0" anchor="ctr"/>
+          <a:lstStyle/>
+          <a:p>
+            <a:pPr algn="ctr"/>
+          </a:p>
+        </p:txBody>
+      </p:sp>
+      <p:sp>
+        <p:nvSpPr>
+          <p:cNvPr id="7" name="Oval 6"/>
+          <p:cNvSpPr/>
+          <p:nvPr/>
+        </p:nvSpPr>
+        <p:spPr>
+          <a:xfrm>
+            <a:off x="8801100" y="2240280"/>
+            <a:ext cx="182880" cy="182880"/>
+          </a:xfrm>
+          <a:prstGeom prst="ellipse">
+            <a:avLst/>
+          </a:prstGeom>
+          <a:solidFill>
+            <a:srgbClr val="2563EB"/>
+          </a:solidFill>
+          <a:ln>
+            <a:noFill/>
+          </a:ln>
+        </p:spPr>
+        <p:style>
+          <a:lnRef idx="1">
+            <a:schemeClr val="accent1"/>
+          </a:lnRef>
+          <a:fillRef idx="3">
+            <a:schemeClr val="accent1"/>
+          </a:fillRef>
+          <a:effectRef idx="2">
+            <a:schemeClr val="accent1"/>
+          </a:effectRef>
+          <a:fontRef idx="minor">
+            <a:schemeClr val="lt1"/>
+          </a:fontRef>
+        </p:style>
+        <p:txBody>
+          <a:bodyPr rtlCol="0" anchor="ctr"/>
+          <a:lstStyle/>
+          <a:p>
+            <a:pPr algn="ctr"/>
+          </a:p>
+        </p:txBody>
+      </p:sp>
+      <p:sp>
+        <p:nvSpPr>
+          <p:cNvPr id="8" name="Oval 7"/>
+          <p:cNvSpPr/>
+          <p:nvPr/>
+        </p:nvSpPr>
+        <p:spPr>
+          <a:xfrm>
+            <a:off x="8801100" y="3017520"/>
+            <a:ext cx="182880" cy="182880"/>
+          </a:xfrm>
+          <a:prstGeom prst="ellipse">
+            <a:avLst/>
+          </a:prstGeom>
+          <a:solidFill>
+            <a:srgbClr val="DBEAFE"/>
+          </a:solidFill>
+          <a:ln>
+            <a:noFill/>
+          </a:ln>
+        </p:spPr>
+        <p:style>
+          <a:lnRef idx="1">
+            <a:schemeClr val="accent1"/>
+          </a:lnRef>
+          <a:fillRef idx="3">
+            <a:schemeClr val="accent1"/>
+          </a:fillRef>
+          <a:effectRef idx="2">
+            <a:schemeClr val="accent1"/>
+          </a:effectRef>
+          <a:fontRef idx="minor">
+            <a:schemeClr val="lt1"/>
+          </a:fontRef>
+        </p:style>
+        <p:txBody>
+          <a:bodyPr rtlCol="0" anchor="ctr"/>
+          <a:lstStyle/>
+          <a:p>
+            <a:pPr algn="ctr"/>
+          </a:p>
+        </p:txBody>
+      </p:sp>
+      <p:sp>
+        <p:nvSpPr>
+          <p:cNvPr id="9" name="Oval 8"/>
+          <p:cNvSpPr/>
+          <p:nvPr/>
+        </p:nvSpPr>
+        <p:spPr>
+          <a:xfrm>
+            <a:off x="8801100" y="3794760"/>
+            <a:ext cx="182880" cy="182880"/>
+          </a:xfrm>
+          <a:prstGeom prst="ellipse">
+            <a:avLst/>
+          </a:prstGeom>
+          <a:solidFill>
+            <a:srgbClr val="DBEAFE"/>
+          </a:solidFill>
+          <a:ln>
+            <a:noFill/>
+          </a:ln>
+        </p:spPr>
+        <p:style>
+          <a:lnRef idx="1">
+            <a:schemeClr val="accent1"/>
+          </a:lnRef>
+          <a:fillRef idx="3">
+            <a:schemeClr val="accent1"/>
+          </a:fillRef>
+          <a:effectRef idx="2">
+            <a:schemeClr val="accent1"/>
+          </a:effectRef>
+          <a:fontRef idx="minor">
+            <a:schemeClr val="lt1"/>
+          </a:fontRef>
+        </p:style>
+        <p:txBody>
+          <a:bodyPr rtlCol="0" anchor="ctr"/>
+          <a:lstStyle/>
+          <a:p>
+            <a:pPr algn="ctr"/>
+          </a:p>
+        </p:txBody>
+      </p:sp>
+      <p:sp>
+        <p:nvSpPr>
+          <p:cNvPr id="10" name="TextBox 9"/>
+          <p:cNvSpPr txBox="1"/>
+          <p:nvPr/>
+        </p:nvSpPr>
+        <p:spPr>
+          <a:xfrm>
+            <a:off x="457200" y="347472"/>
+            <a:ext cx="8092440" cy="411480"/>
+          </a:xfrm>
+          <a:prstGeom prst="rect">
+            <a:avLst/>
+          </a:prstGeom>
+          <a:noFill/>
+        </p:spPr>
+        <p:txBody>
+          <a:bodyPr wrap="square" anchor="ctr">
+            <a:spAutoFit/>
+          </a:bodyPr>
+          <a:lstStyle/>
+          <a:p>
+            <a:pPr algn="r" a:rtl="1"/>
+            <a:r>
+              <a:rPr sz="2400" b="1">
+                <a:solidFill>
+                  <a:srgbClr val="1E293B"/>
+                </a:solidFill>
+                <a:latin typeface="Tahoma"/>
+              </a:rPr>
+              <a:t>بررسی سازگاری ماتریس نهایی</a:t>
+            </a:r>
+          </a:p>
+        </p:txBody>
+      </p:sp>
+      <p:sp>
+        <p:nvSpPr>
+          <p:cNvPr id="11" name="TextBox 10"/>
+          <p:cNvSpPr txBox="1"/>
+          <p:nvPr/>
+        </p:nvSpPr>
+        <p:spPr>
+          <a:xfrm>
+            <a:off x="457200" y="804672"/>
+            <a:ext cx="8092440" cy="274320"/>
+          </a:xfrm>
+          <a:prstGeom prst="rect">
+            <a:avLst/>
+          </a:prstGeom>
+          <a:noFill/>
+        </p:spPr>
+        <p:txBody>
+          <a:bodyPr wrap="square" anchor="ctr">
+            <a:spAutoFit/>
+          </a:bodyPr>
+          <a:lstStyle/>
+          <a:p>
+            <a:pPr algn="r" a:rtl="1"/>
+            <a:r>
+              <a:rPr sz="1100" b="0">
+                <a:solidFill>
+                  <a:srgbClr val="64748B"/>
+                </a:solidFill>
+                <a:latin typeface="Tahoma"/>
+              </a:rPr>
+              <a:t>پس از محاسبه بردار وزن، سازگاری ماتریس تجمیع‌شده بررسی می‌شود</a:t>
+            </a:r>
+          </a:p>
+        </p:txBody>
+      </p:sp>
+      <p:sp>
+        <p:nvSpPr>
+          <p:cNvPr id="12" name="Rounded Rectangle 11"/>
+          <p:cNvSpPr/>
+          <p:nvPr/>
+        </p:nvSpPr>
+        <p:spPr>
+          <a:xfrm>
+            <a:off x="457200" y="1234440"/>
+            <a:ext cx="5897880" cy="2606040"/>
+          </a:xfrm>
+          <a:prstGeom prst="roundRect">
+            <a:avLst>
+              <a:gd name="adj" fmla="val 10000"/>
+            </a:avLst>
+          </a:prstGeom>
+          <a:solidFill>
+            <a:srgbClr val="FFFFFF"/>
+          </a:solidFill>
+          <a:ln w="19050">
+            <a:solidFill>
+              <a:srgbClr val="E2E8F0"/>
+            </a:solidFill>
+          </a:ln>
+        </p:spPr>
+        <p:style>
+          <a:lnRef idx="1">
+            <a:schemeClr val="accent1"/>
+          </a:lnRef>
+          <a:fillRef idx="3">
+            <a:schemeClr val="accent1"/>
+          </a:fillRef>
+          <a:effectRef idx="2">
+            <a:schemeClr val="accent1"/>
+          </a:effectRef>
+          <a:fontRef idx="minor">
+            <a:schemeClr val="lt1"/>
+          </a:fontRef>
+        </p:style>
+        <p:txBody>
+          <a:bodyPr rtlCol="0" anchor="ctr"/>
+          <a:lstStyle/>
+          <a:p>
+            <a:pPr algn="ctr"/>
+          </a:p>
+        </p:txBody>
+      </p:sp>
+      <p:sp>
+        <p:nvSpPr>
+          <p:cNvPr id="13" name="TextBox 12"/>
+          <p:cNvSpPr txBox="1"/>
+          <p:nvPr/>
+        </p:nvSpPr>
+        <p:spPr>
+          <a:xfrm>
+            <a:off x="640080" y="1371600"/>
+            <a:ext cx="5532120" cy="274320"/>
+          </a:xfrm>
+          <a:prstGeom prst="rect">
+            <a:avLst/>
+          </a:prstGeom>
+          <a:noFill/>
+        </p:spPr>
+        <p:txBody>
+          <a:bodyPr wrap="square" anchor="ctr">
+            <a:spAutoFit/>
+          </a:bodyPr>
+          <a:lstStyle/>
+          <a:p>
+            <a:pPr algn="r" a:rtl="1"/>
+            <a:r>
+              <a:rPr sz="1400" b="1">
+                <a:solidFill>
+                  <a:srgbClr val="1D4ED8"/>
+                </a:solidFill>
+                <a:latin typeface="Tahoma"/>
+              </a:rPr>
+              <a:t>زنجیره محاسبه</a:t>
+            </a:r>
+          </a:p>
+        </p:txBody>
+      </p:sp>
+      <p:sp>
+        <p:nvSpPr>
+          <p:cNvPr id="14" name="Right Arrow 13"/>
+          <p:cNvSpPr/>
+          <p:nvPr/>
+        </p:nvSpPr>
+        <p:spPr>
+          <a:xfrm rot="10800000">
+            <a:off x="4361688" y="2281428"/>
+            <a:ext cx="347472" cy="146304"/>
+          </a:xfrm>
+          <a:prstGeom prst="rightArrow">
+            <a:avLst/>
+          </a:prstGeom>
+          <a:solidFill>
+            <a:srgbClr val="CBD5E1"/>
+          </a:solidFill>
+          <a:ln>
+            <a:noFill/>
+          </a:ln>
+        </p:spPr>
+        <p:style>
+          <a:lnRef idx="1">
+            <a:schemeClr val="accent1"/>
+          </a:lnRef>
+          <a:fillRef idx="3">
+            <a:schemeClr val="accent1"/>
+          </a:fillRef>
+          <a:effectRef idx="2">
+            <a:schemeClr val="accent1"/>
+          </a:effectRef>
+          <a:fontRef idx="minor">
+            <a:schemeClr val="lt1"/>
+          </a:fontRef>
+        </p:style>
+        <p:txBody>
+          <a:bodyPr rtlCol="0" anchor="ctr"/>
+          <a:lstStyle/>
+          <a:p>
+            <a:pPr algn="ctr"/>
+          </a:p>
+        </p:txBody>
+      </p:sp>
+      <p:sp>
+        <p:nvSpPr>
+          <p:cNvPr id="15" name="Right Arrow 14"/>
+          <p:cNvSpPr/>
+          <p:nvPr/>
+        </p:nvSpPr>
+        <p:spPr>
+          <a:xfrm rot="10800000">
+            <a:off x="2596896" y="2281428"/>
+            <a:ext cx="347472" cy="146304"/>
+          </a:xfrm>
+          <a:prstGeom prst="rightArrow">
+            <a:avLst/>
+          </a:prstGeom>
+          <a:solidFill>
+            <a:srgbClr val="CBD5E1"/>
+          </a:solidFill>
+          <a:ln>
+            <a:noFill/>
+          </a:ln>
+        </p:spPr>
+        <p:style>
+          <a:lnRef idx="1">
+            <a:schemeClr val="accent1"/>
+          </a:lnRef>
+          <a:fillRef idx="3">
+            <a:schemeClr val="accent1"/>
+          </a:fillRef>
+          <a:effectRef idx="2">
+            <a:schemeClr val="accent1"/>
+          </a:effectRef>
+          <a:fontRef idx="minor">
+            <a:schemeClr val="lt1"/>
+          </a:fontRef>
+        </p:style>
+        <p:txBody>
+          <a:bodyPr rtlCol="0" anchor="ctr"/>
+          <a:lstStyle/>
+          <a:p>
+            <a:pPr algn="ctr"/>
+          </a:p>
+        </p:txBody>
+      </p:sp>
+      <p:sp>
+        <p:nvSpPr>
+          <p:cNvPr id="16" name="Rounded Rectangle 15"/>
+          <p:cNvSpPr/>
+          <p:nvPr/>
+        </p:nvSpPr>
+        <p:spPr>
+          <a:xfrm>
+            <a:off x="4709160" y="1737360"/>
+            <a:ext cx="1417320" cy="1234440"/>
+          </a:xfrm>
+          <a:prstGeom prst="roundRect">
+            <a:avLst>
+              <a:gd name="adj" fmla="val 10000"/>
+            </a:avLst>
+          </a:prstGeom>
+          <a:solidFill>
+            <a:srgbClr val="EFF6FF"/>
+          </a:solidFill>
+          <a:ln w="12700">
+            <a:solidFill>
+              <a:srgbClr val="E2E8F0"/>
+            </a:solidFill>
+          </a:ln>
+        </p:spPr>
+        <p:style>
+          <a:lnRef idx="1">
+            <a:schemeClr val="accent1"/>
+          </a:lnRef>
+          <a:fillRef idx="3">
+            <a:schemeClr val="accent1"/>
+          </a:fillRef>
+          <a:effectRef idx="2">
+            <a:schemeClr val="accent1"/>
+          </a:effectRef>
+          <a:fontRef idx="minor">
+            <a:schemeClr val="lt1"/>
+          </a:fontRef>
+        </p:style>
+        <p:txBody>
+          <a:bodyPr rtlCol="0" anchor="ctr"/>
+          <a:lstStyle/>
+          <a:p>
+            <a:pPr algn="ctr"/>
+          </a:p>
+        </p:txBody>
+      </p:sp>
+      <p:sp>
+        <p:nvSpPr>
+          <p:cNvPr id="17" name="TextBox 16"/>
+          <p:cNvSpPr txBox="1"/>
+          <p:nvPr/>
+        </p:nvSpPr>
+        <p:spPr>
+          <a:xfrm>
+            <a:off x="4782312" y="1847088"/>
+            <a:ext cx="1271016" cy="274320"/>
+          </a:xfrm>
+          <a:prstGeom prst="rect">
+            <a:avLst/>
+          </a:prstGeom>
+          <a:noFill/>
+        </p:spPr>
+        <p:txBody>
+          <a:bodyPr wrap="square" anchor="ctr">
+            <a:spAutoFit/>
+          </a:bodyPr>
+          <a:lstStyle/>
+          <a:p>
+            <a:pPr algn="ctr"/>
+            <a:r>
+              <a:rPr sz="1800" b="1">
+                <a:solidFill>
+                  <a:srgbClr val="2563EB"/>
+                </a:solidFill>
+                <a:latin typeface="Tahoma"/>
+              </a:rPr>
+              <a:t>λmax</a:t>
+            </a:r>
+          </a:p>
+        </p:txBody>
+      </p:sp>
+      <p:sp>
+        <p:nvSpPr>
+          <p:cNvPr id="18" name="TextBox 17"/>
+          <p:cNvSpPr txBox="1"/>
+          <p:nvPr/>
+        </p:nvSpPr>
+        <p:spPr>
+          <a:xfrm>
+            <a:off x="4782312" y="2121408"/>
+            <a:ext cx="1271016" cy="256032"/>
+          </a:xfrm>
+          <a:prstGeom prst="rect">
+            <a:avLst/>
+          </a:prstGeom>
+          <a:noFill/>
+        </p:spPr>
+        <p:txBody>
+          <a:bodyPr wrap="square" anchor="ctr">
+            <a:spAutoFit/>
+          </a:bodyPr>
+          <a:lstStyle/>
+          <a:p>
+            <a:pPr algn="ctr" a:rtl="1"/>
+            <a:r>
+              <a:rPr sz="1000" b="1">
+                <a:solidFill>
+                  <a:srgbClr val="1E293B"/>
+                </a:solidFill>
+                <a:latin typeface="Tahoma"/>
+              </a:rPr>
+              <a:t>مقدار ویژه بیشینه</a:t>
+            </a:r>
+          </a:p>
+        </p:txBody>
+      </p:sp>
+      <p:sp>
+        <p:nvSpPr>
+          <p:cNvPr id="19" name="TextBox 18"/>
+          <p:cNvSpPr txBox="1"/>
+          <p:nvPr/>
+        </p:nvSpPr>
+        <p:spPr>
+          <a:xfrm>
+            <a:off x="4782312" y="2395728"/>
+            <a:ext cx="1271016" cy="457200"/>
+          </a:xfrm>
+          <a:prstGeom prst="rect">
+            <a:avLst/>
+          </a:prstGeom>
+          <a:noFill/>
+        </p:spPr>
+        <p:txBody>
+          <a:bodyPr wrap="square" anchor="ctr">
+            <a:spAutoFit/>
+          </a:bodyPr>
+          <a:lstStyle/>
+          <a:p>
+            <a:pPr algn="ctr" a:rtl="1"/>
+            <a:r>
+              <a:rPr sz="850" b="0">
+                <a:solidFill>
+                  <a:srgbClr val="64748B"/>
+                </a:solidFill>
+                <a:latin typeface="Tahoma"/>
+              </a:rPr>
+              <a:t>از ماتریس تجمیع‌شده و بردار وزن</a:t>
+            </a:r>
+          </a:p>
+        </p:txBody>
+      </p:sp>
+      <p:sp>
+        <p:nvSpPr>
+          <p:cNvPr id="20" name="Rounded Rectangle 19"/>
+          <p:cNvSpPr/>
+          <p:nvPr/>
+        </p:nvSpPr>
+        <p:spPr>
+          <a:xfrm>
+            <a:off x="2944368" y="1737360"/>
+            <a:ext cx="1417320" cy="1234440"/>
+          </a:xfrm>
+          <a:prstGeom prst="roundRect">
+            <a:avLst>
+              <a:gd name="adj" fmla="val 10000"/>
+            </a:avLst>
+          </a:prstGeom>
+          <a:solidFill>
+            <a:srgbClr val="EFF6FF"/>
+          </a:solidFill>
+          <a:ln w="12700">
+            <a:solidFill>
+              <a:srgbClr val="E2E8F0"/>
+            </a:solidFill>
+          </a:ln>
+        </p:spPr>
+        <p:style>
+          <a:lnRef idx="1">
+            <a:schemeClr val="accent1"/>
+          </a:lnRef>
+          <a:fillRef idx="3">
+            <a:schemeClr val="accent1"/>
+          </a:fillRef>
+          <a:effectRef idx="2">
+            <a:schemeClr val="accent1"/>
+          </a:effectRef>
+          <a:fontRef idx="minor">
+            <a:schemeClr val="lt1"/>
+          </a:fontRef>
+        </p:style>
+        <p:txBody>
+          <a:bodyPr rtlCol="0" anchor="ctr"/>
+          <a:lstStyle/>
+          <a:p>
+            <a:pPr algn="ctr"/>
+          </a:p>
+        </p:txBody>
+      </p:sp>
+      <p:sp>
+        <p:nvSpPr>
+          <p:cNvPr id="21" name="TextBox 20"/>
+          <p:cNvSpPr txBox="1"/>
+          <p:nvPr/>
+        </p:nvSpPr>
+        <p:spPr>
+          <a:xfrm>
+            <a:off x="3017520" y="1847088"/>
+            <a:ext cx="1271016" cy="274320"/>
+          </a:xfrm>
+          <a:prstGeom prst="rect">
+            <a:avLst/>
+          </a:prstGeom>
+          <a:noFill/>
+        </p:spPr>
+        <p:txBody>
+          <a:bodyPr wrap="square" anchor="ctr">
+            <a:spAutoFit/>
+          </a:bodyPr>
+          <a:lstStyle/>
+          <a:p>
+            <a:pPr algn="ctr"/>
+            <a:r>
+              <a:rPr sz="1800" b="1">
+                <a:solidFill>
+                  <a:srgbClr val="2563EB"/>
+                </a:solidFill>
+                <a:latin typeface="Tahoma"/>
+              </a:rPr>
+              <a:t>CI</a:t>
+            </a:r>
+          </a:p>
+        </p:txBody>
+      </p:sp>
+      <p:sp>
+        <p:nvSpPr>
+          <p:cNvPr id="22" name="TextBox 21"/>
+          <p:cNvSpPr txBox="1"/>
+          <p:nvPr/>
+        </p:nvSpPr>
+        <p:spPr>
+          <a:xfrm>
+            <a:off x="3017520" y="2121408"/>
+            <a:ext cx="1271016" cy="256032"/>
+          </a:xfrm>
+          <a:prstGeom prst="rect">
+            <a:avLst/>
+          </a:prstGeom>
+          <a:noFill/>
+        </p:spPr>
+        <p:txBody>
+          <a:bodyPr wrap="square" anchor="ctr">
+            <a:spAutoFit/>
+          </a:bodyPr>
+          <a:lstStyle/>
+          <a:p>
+            <a:pPr algn="ctr" a:rtl="1"/>
+            <a:r>
+              <a:rPr sz="1000" b="1">
+                <a:solidFill>
+                  <a:srgbClr val="1E293B"/>
+                </a:solidFill>
+                <a:latin typeface="Tahoma"/>
+              </a:rPr>
+              <a:t>شاخص سازگاری</a:t>
+            </a:r>
+          </a:p>
+        </p:txBody>
+      </p:sp>
+      <p:sp>
+        <p:nvSpPr>
+          <p:cNvPr id="23" name="TextBox 22"/>
+          <p:cNvSpPr txBox="1"/>
+          <p:nvPr/>
+        </p:nvSpPr>
+        <p:spPr>
+          <a:xfrm>
+            <a:off x="3017520" y="2395728"/>
+            <a:ext cx="1271016" cy="457200"/>
+          </a:xfrm>
+          <a:prstGeom prst="rect">
+            <a:avLst/>
+          </a:prstGeom>
+          <a:noFill/>
+        </p:spPr>
+        <p:txBody>
+          <a:bodyPr wrap="square" anchor="ctr">
+            <a:spAutoFit/>
+          </a:bodyPr>
+          <a:lstStyle/>
+          <a:p>
+            <a:pPr algn="ctr" a:rtl="1"/>
+            <a:r>
+              <a:rPr sz="850" b="0">
+                <a:solidFill>
+                  <a:srgbClr val="64748B"/>
+                </a:solidFill>
+                <a:latin typeface="Tahoma"/>
+              </a:rPr>
+              <a:t>CI = (λmax − n) / (n − 1)</a:t>
+            </a:r>
+          </a:p>
+        </p:txBody>
+      </p:sp>
+      <p:sp>
+        <p:nvSpPr>
+          <p:cNvPr id="24" name="Rounded Rectangle 23"/>
+          <p:cNvSpPr/>
+          <p:nvPr/>
+        </p:nvSpPr>
+        <p:spPr>
+          <a:xfrm>
+            <a:off x="1179576" y="1737360"/>
+            <a:ext cx="1417320" cy="1234440"/>
+          </a:xfrm>
+          <a:prstGeom prst="roundRect">
+            <a:avLst>
+              <a:gd name="adj" fmla="val 10000"/>
+            </a:avLst>
+          </a:prstGeom>
+          <a:solidFill>
+            <a:srgbClr val="DBEAFE"/>
+          </a:solidFill>
+          <a:ln w="25400">
+            <a:solidFill>
+              <a:srgbClr val="2563EB"/>
+            </a:solidFill>
+          </a:ln>
+        </p:spPr>
+        <p:style>
+          <a:lnRef idx="1">
+            <a:schemeClr val="accent1"/>
+          </a:lnRef>
+          <a:fillRef idx="3">
+            <a:schemeClr val="accent1"/>
+          </a:fillRef>
+          <a:effectRef idx="2">
+            <a:schemeClr val="accent1"/>
+          </a:effectRef>
+          <a:fontRef idx="minor">
+            <a:schemeClr val="lt1"/>
+          </a:fontRef>
+        </p:style>
+        <p:txBody>
+          <a:bodyPr rtlCol="0" anchor="ctr"/>
+          <a:lstStyle/>
+          <a:p>
+            <a:pPr algn="ctr"/>
+          </a:p>
+        </p:txBody>
+      </p:sp>
+      <p:sp>
+        <p:nvSpPr>
+          <p:cNvPr id="25" name="TextBox 24"/>
+          <p:cNvSpPr txBox="1"/>
+          <p:nvPr/>
+        </p:nvSpPr>
+        <p:spPr>
+          <a:xfrm>
+            <a:off x="1252728" y="1847088"/>
+            <a:ext cx="1271016" cy="274320"/>
+          </a:xfrm>
+          <a:prstGeom prst="rect">
+            <a:avLst/>
+          </a:prstGeom>
+          <a:noFill/>
+        </p:spPr>
+        <p:txBody>
+          <a:bodyPr wrap="square" anchor="ctr">
+            <a:spAutoFit/>
+          </a:bodyPr>
+          <a:lstStyle/>
+          <a:p>
+            <a:pPr algn="ctr"/>
+            <a:r>
+              <a:rPr sz="1800" b="1">
+                <a:solidFill>
+                  <a:srgbClr val="1D4ED8"/>
+                </a:solidFill>
+                <a:latin typeface="Tahoma"/>
+              </a:rPr>
+              <a:t>CR</a:t>
+            </a:r>
+          </a:p>
+        </p:txBody>
+      </p:sp>
+      <p:sp>
+        <p:nvSpPr>
+          <p:cNvPr id="26" name="TextBox 25"/>
+          <p:cNvSpPr txBox="1"/>
+          <p:nvPr/>
+        </p:nvSpPr>
+        <p:spPr>
+          <a:xfrm>
+            <a:off x="1252728" y="2121408"/>
+            <a:ext cx="1271016" cy="256032"/>
+          </a:xfrm>
+          <a:prstGeom prst="rect">
+            <a:avLst/>
+          </a:prstGeom>
+          <a:noFill/>
+        </p:spPr>
+        <p:txBody>
+          <a:bodyPr wrap="square" anchor="ctr">
+            <a:spAutoFit/>
+          </a:bodyPr>
+          <a:lstStyle/>
+          <a:p>
+            <a:pPr algn="ctr" a:rtl="1"/>
+            <a:r>
+              <a:rPr sz="1000" b="1">
+                <a:solidFill>
+                  <a:srgbClr val="1E293B"/>
+                </a:solidFill>
+                <a:latin typeface="Tahoma"/>
+              </a:rPr>
+              <a:t>نرخ سازگاری</a:t>
+            </a:r>
+          </a:p>
+        </p:txBody>
+      </p:sp>
+      <p:sp>
+        <p:nvSpPr>
+          <p:cNvPr id="27" name="TextBox 26"/>
+          <p:cNvSpPr txBox="1"/>
+          <p:nvPr/>
+        </p:nvSpPr>
+        <p:spPr>
+          <a:xfrm>
+            <a:off x="1252728" y="2395728"/>
+            <a:ext cx="1271016" cy="457200"/>
+          </a:xfrm>
+          <a:prstGeom prst="rect">
+            <a:avLst/>
+          </a:prstGeom>
+          <a:noFill/>
+        </p:spPr>
+        <p:txBody>
+          <a:bodyPr wrap="square" anchor="ctr">
+            <a:spAutoFit/>
+          </a:bodyPr>
+          <a:lstStyle/>
+          <a:p>
+            <a:pPr algn="ctr" a:rtl="1"/>
+            <a:r>
+              <a:rPr sz="850" b="0">
+                <a:solidFill>
+                  <a:srgbClr val="64748B"/>
+                </a:solidFill>
+                <a:latin typeface="Tahoma"/>
+              </a:rPr>
+              <a:t>CR = CI / RI</a:t>
+            </a:r>
+          </a:p>
+        </p:txBody>
+      </p:sp>
+      <p:sp>
+        <p:nvSpPr>
+          <p:cNvPr id="28" name="Rounded Rectangle 27"/>
+          <p:cNvSpPr/>
+          <p:nvPr/>
+        </p:nvSpPr>
+        <p:spPr>
+          <a:xfrm>
+            <a:off x="685800" y="3172968"/>
+            <a:ext cx="1188720" cy="292608"/>
+          </a:xfrm>
+          <a:prstGeom prst="roundRect">
+            <a:avLst>
+              <a:gd name="adj" fmla="val 10000"/>
+            </a:avLst>
+          </a:prstGeom>
+          <a:solidFill>
+            <a:srgbClr val="EFF6FF"/>
+          </a:solidFill>
+          <a:ln w="19050">
+            <a:solidFill>
+              <a:srgbClr val="2563EB"/>
+            </a:solidFill>
+          </a:ln>
+        </p:spPr>
+        <p:style>
+          <a:lnRef idx="1">
+            <a:schemeClr val="accent1"/>
+          </a:lnRef>
+          <a:fillRef idx="3">
+            <a:schemeClr val="accent1"/>
+          </a:fillRef>
+          <a:effectRef idx="2">
+            <a:schemeClr val="accent1"/>
+          </a:effectRef>
+          <a:fontRef idx="minor">
+            <a:schemeClr val="lt1"/>
+          </a:fontRef>
+        </p:style>
+        <p:txBody>
+          <a:bodyPr rtlCol="0" anchor="ctr"/>
+          <a:lstStyle/>
+          <a:p>
+            <a:pPr algn="ctr" a:rtl="1"/>
+            <a:r>
+              <a:rPr sz="900" b="1">
+                <a:solidFill>
+                  <a:srgbClr val="1D4ED8"/>
+                </a:solidFill>
+                <a:latin typeface="Tahoma"/>
+              </a:rPr>
+              <a:t>n = 8 معیار</a:t>
+            </a:r>
+          </a:p>
+        </p:txBody>
+      </p:sp>
+      <p:sp>
+        <p:nvSpPr>
+          <p:cNvPr id="29" name="Rounded Rectangle 28"/>
+          <p:cNvSpPr/>
+          <p:nvPr/>
+        </p:nvSpPr>
+        <p:spPr>
+          <a:xfrm>
+            <a:off x="1965960" y="3172968"/>
+            <a:ext cx="1417320" cy="292608"/>
+          </a:xfrm>
+          <a:prstGeom prst="roundRect">
+            <a:avLst>
+              <a:gd name="adj" fmla="val 10000"/>
+            </a:avLst>
+          </a:prstGeom>
+          <a:solidFill>
+            <a:srgbClr val="EFF6FF"/>
+          </a:solidFill>
+          <a:ln w="19050">
+            <a:solidFill>
+              <a:srgbClr val="2563EB"/>
+            </a:solidFill>
+          </a:ln>
+        </p:spPr>
+        <p:style>
+          <a:lnRef idx="1">
+            <a:schemeClr val="accent1"/>
+          </a:lnRef>
+          <a:fillRef idx="3">
+            <a:schemeClr val="accent1"/>
+          </a:fillRef>
+          <a:effectRef idx="2">
+            <a:schemeClr val="accent1"/>
+          </a:effectRef>
+          <a:fontRef idx="minor">
+            <a:schemeClr val="lt1"/>
+          </a:fontRef>
+        </p:style>
+        <p:txBody>
+          <a:bodyPr rtlCol="0" anchor="ctr"/>
+          <a:lstStyle/>
+          <a:p>
+            <a:pPr algn="ctr" a:rtl="1"/>
+            <a:r>
+              <a:rPr sz="900" b="1">
+                <a:solidFill>
+                  <a:srgbClr val="1D4ED8"/>
+                </a:solidFill>
+                <a:latin typeface="Tahoma"/>
+              </a:rPr>
+              <a:t>RI = 1.41 (جدول ساعتی)</a:t>
+            </a:r>
+          </a:p>
+        </p:txBody>
+      </p:sp>
+      <p:sp>
+        <p:nvSpPr>
+          <p:cNvPr id="30" name="TextBox 29"/>
+          <p:cNvSpPr txBox="1"/>
+          <p:nvPr/>
+        </p:nvSpPr>
+        <p:spPr>
+          <a:xfrm>
+            <a:off x="685800" y="3557016"/>
+            <a:ext cx="5440680" cy="320040"/>
+          </a:xfrm>
+          <a:prstGeom prst="rect">
+            <a:avLst/>
+          </a:prstGeom>
+          <a:noFill/>
+        </p:spPr>
+        <p:txBody>
+          <a:bodyPr wrap="square" anchor="ctr">
+            <a:spAutoFit/>
+          </a:bodyPr>
+          <a:lstStyle/>
+          <a:p>
+            <a:pPr algn="r" a:rtl="1"/>
+            <a:r>
+              <a:rPr sz="900" b="0">
+                <a:solidFill>
+                  <a:srgbClr val="64748B"/>
+                </a:solidFill>
+                <a:latin typeface="Tahoma"/>
+              </a:rPr>
+              <a:t>مثال: CI = 0.05  →  CR = 0.05 / 1.41 ≈ 0.035  →  قابل قبول ✓</a:t>
+            </a:r>
+          </a:p>
+        </p:txBody>
+      </p:sp>
+      <p:sp>
+        <p:nvSpPr>
+          <p:cNvPr id="31" name="Rounded Rectangle 30"/>
+          <p:cNvSpPr/>
+          <p:nvPr/>
+        </p:nvSpPr>
+        <p:spPr>
+          <a:xfrm>
+            <a:off x="6537960" y="1234440"/>
+            <a:ext cx="2011680" cy="2606040"/>
+          </a:xfrm>
+          <a:prstGeom prst="roundRect">
+            <a:avLst>
+              <a:gd name="adj" fmla="val 10000"/>
+            </a:avLst>
+          </a:prstGeom>
+          <a:solidFill>
+            <a:srgbClr val="FFFFFF"/>
+          </a:solidFill>
+          <a:ln w="19050">
+            <a:solidFill>
+              <a:srgbClr val="E2E8F0"/>
+            </a:solidFill>
+          </a:ln>
+        </p:spPr>
+        <p:style>
+          <a:lnRef idx="1">
+            <a:schemeClr val="accent1"/>
+          </a:lnRef>
+          <a:fillRef idx="3">
+            <a:schemeClr val="accent1"/>
+          </a:fillRef>
+          <a:effectRef idx="2">
+            <a:schemeClr val="accent1"/>
+          </a:effectRef>
+          <a:fontRef idx="minor">
+            <a:schemeClr val="lt1"/>
+          </a:fontRef>
+        </p:style>
+        <p:txBody>
+          <a:bodyPr rtlCol="0" anchor="ctr"/>
+          <a:lstStyle/>
+          <a:p>
+            <a:pPr algn="ctr"/>
+          </a:p>
+        </p:txBody>
+      </p:sp>
+      <p:sp>
+        <p:nvSpPr>
+          <p:cNvPr id="32" name="TextBox 31"/>
+          <p:cNvSpPr txBox="1"/>
+          <p:nvPr/>
+        </p:nvSpPr>
+        <p:spPr>
+          <a:xfrm>
+            <a:off x="6629400" y="1371600"/>
+            <a:ext cx="1828800" cy="274320"/>
+          </a:xfrm>
+          <a:prstGeom prst="rect">
+            <a:avLst/>
+          </a:prstGeom>
+          <a:noFill/>
+        </p:spPr>
+        <p:txBody>
+          <a:bodyPr wrap="square" anchor="ctr">
+            <a:spAutoFit/>
+          </a:bodyPr>
+          <a:lstStyle/>
+          <a:p>
+            <a:pPr algn="ctr" a:rtl="1"/>
+            <a:r>
+              <a:rPr sz="1400" b="1">
+                <a:solidFill>
+                  <a:srgbClr val="1D4ED8"/>
+                </a:solidFill>
+                <a:latin typeface="Tahoma"/>
+              </a:rPr>
+              <a:t>معیار پذیرش</a:t>
+            </a:r>
+          </a:p>
+        </p:txBody>
+      </p:sp>
+      <p:sp>
+        <p:nvSpPr>
+          <p:cNvPr id="33" name="Rounded Rectangle 32"/>
+          <p:cNvSpPr/>
+          <p:nvPr/>
+        </p:nvSpPr>
+        <p:spPr>
+          <a:xfrm>
+            <a:off x="6675120" y="1737360"/>
+            <a:ext cx="1737360" cy="594360"/>
+          </a:xfrm>
+          <a:prstGeom prst="roundRect">
+            <a:avLst>
+              <a:gd name="adj" fmla="val 10000"/>
+            </a:avLst>
+          </a:prstGeom>
+          <a:solidFill>
+            <a:srgbClr val="2563EB"/>
+          </a:solidFill>
+          <a:ln>
+            <a:noFill/>
+          </a:ln>
+        </p:spPr>
+        <p:style>
+          <a:lnRef idx="1">
+            <a:schemeClr val="accent1"/>
+          </a:lnRef>
+          <a:fillRef idx="3">
+            <a:schemeClr val="accent1"/>
+          </a:fillRef>
+          <a:effectRef idx="2">
+            <a:schemeClr val="accent1"/>
+          </a:effectRef>
+          <a:fontRef idx="minor">
+            <a:schemeClr val="lt1"/>
+          </a:fontRef>
+        </p:style>
+        <p:txBody>
+          <a:bodyPr rtlCol="0" anchor="ctr"/>
+          <a:lstStyle/>
+          <a:p>
+            <a:pPr algn="ctr"/>
+          </a:p>
+        </p:txBody>
+      </p:sp>
+      <p:sp>
+        <p:nvSpPr>
+          <p:cNvPr id="34" name="TextBox 33"/>
+          <p:cNvSpPr txBox="1"/>
+          <p:nvPr/>
+        </p:nvSpPr>
+        <p:spPr>
+          <a:xfrm>
+            <a:off x="6675120" y="1856232"/>
+            <a:ext cx="1737360" cy="365760"/>
+          </a:xfrm>
+          <a:prstGeom prst="rect">
+            <a:avLst/>
+          </a:prstGeom>
+          <a:noFill/>
+        </p:spPr>
+        <p:txBody>
+          <a:bodyPr wrap="square" anchor="ctr">
+            <a:spAutoFit/>
+          </a:bodyPr>
+          <a:lstStyle/>
+          <a:p>
+            <a:pPr algn="ctr"/>
+            <a:r>
+              <a:rPr sz="2200" b="1">
                 <a:solidFill>
                   <a:srgbClr val="FFFFFF"/>
                 </a:solidFill>
                 <a:latin typeface="Tahoma"/>
               </a:rPr>
-              <a:t>n = 8</a:t>
-            </a:r>
-          </a:p>
-        </p:txBody>
-      </p:sp>
-      <p:graphicFrame>
-        <p:nvGraphicFramePr>
-          <p:cNvPr id="8" name="Table 7"/>
-          <p:cNvGraphicFramePr>
-            <a:graphicFrameLocks noGrp="1"/>
-          </p:cNvGraphicFramePr>
-          <p:nvPr/>
-        </p:nvGraphicFramePr>
-        <p:xfrm>
-          <a:off x="502920" y="1417320"/>
-          <a:ext cx="5989319" cy="3063240"/>
-        </p:xfrm>
-        <a:graphic>
-          <a:graphicData uri="http://schemas.openxmlformats.org/drawingml/2006/table">
-            <a:tbl>
-              <a:tblPr firstRow="1" bandRow="1">
-                <a:tableStyleId>{5C22544A-7EE6-4342-B048-85BDC9FD1C3A}</a:tableStyleId>
-                <a:tblBorders>
-                  <a:bottom w="0" cap="flat" cmpd="sng" algn="ctr">
-                    <a:noFill/>
-                  </a:bottom>
-                  <a:top w="0" cap="flat" cmpd="sng" algn="ctr">
-                    <a:noFill/>
-                  </a:top>
-                  <a:left w="0" cap="flat" cmpd="sng" algn="ctr">
-                    <a:noFill/>
-                  </a:left>
-                  <a:right w="0" cap="flat" cmpd="sng" algn="ctr">
-                    <a:noFill/>
-                  </a:right>
-                  <a:insideH w="0" cap="flat" cmpd="sng" algn="ctr">
-                    <a:noFill/>
-                  </a:insideH>
-                  <a:insideV w="0" cap="flat" cmpd="sng" algn="ctr">
-                    <a:noFill/>
-                  </a:insideV>
-                </a:tblBorders>
-              </a:tblPr>
-              <a:tblGrid>
-                <a:gridCol w="1874519"/>
-                <a:gridCol w="1051560"/>
-                <a:gridCol w="3063240"/>
-              </a:tblGrid>
-              <a:tr h="437605">
-                <a:tc>
-                  <a:txBody>
-                    <a:bodyPr anchor="ctr"/>
-                    <a:lstStyle/>
-                    <a:p>
-                      <a:pPr algn="ctr" a:rtl="1"/>
-                      <a:r>
-                        <a:rPr sz="1300" b="1">
-                          <a:solidFill>
-                            <a:srgbClr val="FFFFFF"/>
-                          </a:solidFill>
-                          <a:latin typeface="Tahoma"/>
-                        </a:rPr>
-                        <a:t>شاخص</a:t>
-                      </a:r>
-                    </a:p>
-                  </a:txBody>
-                  <a:tcPr marL="76200" marR="76200" marT="50800" marB="50800">
-                    <a:solidFill>
-                      <a:srgbClr val="1E3A5F"/>
-                    </a:solidFill>
-                    <a:tcBdr>
-                      <a:bottom w="19050" cap="flat" cmpd="sng" algn="ctr">
-                        <a:solidFill>
-                          <a:srgbClr val="2B5C8A"/>
-                        </a:solidFill>
-                      </a:bottom>
-                    </a:tcBdr>
-                  </a:tcPr>
-                </a:tc>
-                <a:tc>
-                  <a:txBody>
-                    <a:bodyPr anchor="ctr"/>
-                    <a:lstStyle/>
-                    <a:p>
-                      <a:pPr algn="ctr" a:rtl="1"/>
-                      <a:r>
-                        <a:rPr sz="1300" b="1">
-                          <a:solidFill>
-                            <a:srgbClr val="FFFFFF"/>
-                          </a:solidFill>
-                          <a:latin typeface="Tahoma"/>
-                        </a:rPr>
-                        <a:t>نماد</a:t>
-                      </a:r>
-                    </a:p>
-                  </a:txBody>
-                  <a:tcPr marL="76200" marR="76200" marT="50800" marB="50800">
-                    <a:solidFill>
-                      <a:srgbClr val="1E3A5F"/>
-                    </a:solidFill>
-                    <a:tcBdr>
-                      <a:bottom w="19050" cap="flat" cmpd="sng" algn="ctr">
-                        <a:solidFill>
-                          <a:srgbClr val="2B5C8A"/>
-                        </a:solidFill>
-                      </a:bottom>
-                    </a:tcBdr>
-                  </a:tcPr>
-                </a:tc>
-                <a:tc>
-                  <a:txBody>
-                    <a:bodyPr anchor="ctr"/>
-                    <a:lstStyle/>
-                    <a:p>
-                      <a:pPr algn="ctr" a:rtl="1"/>
-                      <a:r>
-                        <a:rPr sz="1300" b="1">
-                          <a:solidFill>
-                            <a:srgbClr val="FFFFFF"/>
-                          </a:solidFill>
-                          <a:latin typeface="Tahoma"/>
-                        </a:rPr>
-                        <a:t>توضیح / فرمول</a:t>
-                      </a:r>
-                    </a:p>
-                  </a:txBody>
-                  <a:tcPr marL="76200" marR="76200" marT="50800" marB="50800">
-                    <a:solidFill>
-                      <a:srgbClr val="1E3A5F"/>
-                    </a:solidFill>
-                    <a:tcBdr>
-                      <a:bottom w="19050" cap="flat" cmpd="sng" algn="ctr">
-                        <a:solidFill>
-                          <a:srgbClr val="2B5C8A"/>
-                        </a:solidFill>
-                      </a:bottom>
-                    </a:tcBdr>
-                  </a:tcPr>
-                </a:tc>
-              </a:tr>
-              <a:tr h="437605">
-                <a:tc>
-                  <a:txBody>
-                    <a:bodyPr anchor="ctr"/>
-                    <a:lstStyle/>
-                    <a:p>
-                      <a:pPr algn="r" a:rtl="1"/>
-                      <a:r>
-                        <a:rPr sz="1200" b="0">
-                          <a:solidFill>
-                            <a:srgbClr val="2D343E"/>
-                          </a:solidFill>
-                          <a:latin typeface="Tahoma"/>
-                        </a:rPr>
-                        <a:t>تعداد معیارها</a:t>
-                      </a:r>
-                    </a:p>
-                  </a:txBody>
-                  <a:tcPr marL="76200" marR="76200" marT="50800" marB="50800">
-                    <a:solidFill>
-                      <a:srgbClr val="FFFFFF"/>
-                    </a:solidFill>
-                    <a:tcBdr>
-                      <a:bottom w="12700" cap="flat" cmpd="sng" algn="ctr">
-                        <a:solidFill>
-                          <a:srgbClr val="D1D9E6"/>
-                        </a:solidFill>
-                      </a:bottom>
-                    </a:tcBdr>
-                  </a:tcPr>
-                </a:tc>
-                <a:tc>
-                  <a:txBody>
-                    <a:bodyPr anchor="ctr"/>
-                    <a:lstStyle/>
-                    <a:p>
-                      <a:pPr algn="ctr" a:rtl="1"/>
-                      <a:r>
-                        <a:rPr sz="1200" b="1">
-                          <a:solidFill>
-                            <a:srgbClr val="2D343E"/>
-                          </a:solidFill>
-                          <a:latin typeface="Tahoma"/>
-                        </a:rPr>
-                        <a:t>8</a:t>
-                      </a:r>
-                    </a:p>
-                  </a:txBody>
-                  <a:tcPr marL="76200" marR="76200" marT="50800" marB="50800">
-                    <a:solidFill>
-                      <a:srgbClr val="FFFFFF"/>
-                    </a:solidFill>
-                    <a:tcBdr>
-                      <a:bottom w="12700" cap="flat" cmpd="sng" algn="ctr">
-                        <a:solidFill>
-                          <a:srgbClr val="D1D9E6"/>
-                        </a:solidFill>
-                      </a:bottom>
-                    </a:tcBdr>
-                  </a:tcPr>
-                </a:tc>
-                <a:tc>
-                  <a:txBody>
-                    <a:bodyPr anchor="ctr"/>
-                    <a:lstStyle/>
-                    <a:p>
-                      <a:pPr algn="r" a:rtl="1"/>
-                      <a:r>
-                        <a:rPr sz="1200" b="0">
-                          <a:solidFill>
-                            <a:srgbClr val="2D343E"/>
-                          </a:solidFill>
-                          <a:latin typeface="Tahoma"/>
-                        </a:rPr>
-                        <a:t>تعداد معیارهای سطح اول</a:t>
-                      </a:r>
-                    </a:p>
-                  </a:txBody>
-                  <a:tcPr marL="76200" marR="76200" marT="50800" marB="50800">
-                    <a:solidFill>
-                      <a:srgbClr val="FFFFFF"/>
-                    </a:solidFill>
-                    <a:tcBdr>
-                      <a:bottom w="12700" cap="flat" cmpd="sng" algn="ctr">
-                        <a:solidFill>
-                          <a:srgbClr val="D1D9E6"/>
-                        </a:solidFill>
-                      </a:bottom>
-                    </a:tcBdr>
-                  </a:tcPr>
-                </a:tc>
-              </a:tr>
-              <a:tr h="437605">
-                <a:tc>
-                  <a:txBody>
-                    <a:bodyPr anchor="ctr"/>
-                    <a:lstStyle/>
-                    <a:p>
-                      <a:pPr algn="r" a:rtl="1"/>
-                      <a:r>
-                        <a:rPr sz="1200" b="0">
-                          <a:solidFill>
-                            <a:srgbClr val="2D343E"/>
-                          </a:solidFill>
-                          <a:latin typeface="Tahoma"/>
-                        </a:rPr>
-                        <a:t>مقدار ویژه بیشینه</a:t>
-                      </a:r>
-                    </a:p>
-                  </a:txBody>
-                  <a:tcPr marL="76200" marR="76200" marT="50800" marB="50800">
-                    <a:solidFill>
-                      <a:srgbClr val="F0F4F8"/>
-                    </a:solidFill>
-                    <a:tcBdr>
-                      <a:bottom w="12700" cap="flat" cmpd="sng" algn="ctr">
-                        <a:solidFill>
-                          <a:srgbClr val="D1D9E6"/>
-                        </a:solidFill>
-                      </a:bottom>
-                    </a:tcBdr>
-                  </a:tcPr>
-                </a:tc>
-                <a:tc>
-                  <a:txBody>
-                    <a:bodyPr anchor="ctr"/>
-                    <a:lstStyle/>
-                    <a:p>
-                      <a:pPr algn="ctr" a:rtl="1"/>
-                      <a:r>
-                        <a:rPr sz="1200" b="1">
-                          <a:solidFill>
-                            <a:srgbClr val="2D343E"/>
-                          </a:solidFill>
-                          <a:latin typeface="Tahoma"/>
-                        </a:rPr>
-                        <a:t>λmax</a:t>
-                      </a:r>
-                    </a:p>
-                  </a:txBody>
-                  <a:tcPr marL="76200" marR="76200" marT="50800" marB="50800">
-                    <a:solidFill>
-                      <a:srgbClr val="F0F4F8"/>
-                    </a:solidFill>
-                    <a:tcBdr>
-                      <a:bottom w="12700" cap="flat" cmpd="sng" algn="ctr">
-                        <a:solidFill>
-                          <a:srgbClr val="D1D9E6"/>
-                        </a:solidFill>
-                      </a:bottom>
-                    </a:tcBdr>
-                  </a:tcPr>
-                </a:tc>
-                <a:tc>
-                  <a:txBody>
-                    <a:bodyPr anchor="ctr"/>
-                    <a:lstStyle/>
-                    <a:p>
-                      <a:pPr algn="r" a:rtl="1"/>
-                      <a:r>
-                        <a:rPr sz="1200" b="0">
-                          <a:solidFill>
-                            <a:srgbClr val="2D343E"/>
-                          </a:solidFill>
-                          <a:latin typeface="Tahoma"/>
-                        </a:rPr>
-                        <a:t>λmax = (1/n) × Σ (AW)i / wi</a:t>
-                      </a:r>
-                    </a:p>
-                  </a:txBody>
-                  <a:tcPr marL="76200" marR="76200" marT="50800" marB="50800">
-                    <a:solidFill>
-                      <a:srgbClr val="F0F4F8"/>
-                    </a:solidFill>
-                    <a:tcBdr>
-                      <a:bottom w="12700" cap="flat" cmpd="sng" algn="ctr">
-                        <a:solidFill>
-                          <a:srgbClr val="D1D9E6"/>
-                        </a:solidFill>
-                      </a:bottom>
-                    </a:tcBdr>
-                  </a:tcPr>
-                </a:tc>
-              </a:tr>
-              <a:tr h="437605">
-                <a:tc>
-                  <a:txBody>
-                    <a:bodyPr anchor="ctr"/>
-                    <a:lstStyle/>
-                    <a:p>
-                      <a:pPr algn="r" a:rtl="1"/>
-                      <a:r>
-                        <a:rPr sz="1200" b="0">
-                          <a:solidFill>
-                            <a:srgbClr val="2D343E"/>
-                          </a:solidFill>
-                          <a:latin typeface="Tahoma"/>
-                        </a:rPr>
-                        <a:t>شاخص سازگاری</a:t>
-                      </a:r>
-                    </a:p>
-                  </a:txBody>
-                  <a:tcPr marL="76200" marR="76200" marT="50800" marB="50800">
-                    <a:solidFill>
-                      <a:srgbClr val="FFFFFF"/>
-                    </a:solidFill>
-                    <a:tcBdr>
-                      <a:bottom w="12700" cap="flat" cmpd="sng" algn="ctr">
-                        <a:solidFill>
-                          <a:srgbClr val="D1D9E6"/>
-                        </a:solidFill>
-                      </a:bottom>
-                    </a:tcBdr>
-                  </a:tcPr>
-                </a:tc>
-                <a:tc>
-                  <a:txBody>
-                    <a:bodyPr anchor="ctr"/>
-                    <a:lstStyle/>
-                    <a:p>
-                      <a:pPr algn="ctr" a:rtl="1"/>
-                      <a:r>
-                        <a:rPr sz="1200" b="1">
-                          <a:solidFill>
-                            <a:srgbClr val="2D343E"/>
-                          </a:solidFill>
-                          <a:latin typeface="Tahoma"/>
-                        </a:rPr>
-                        <a:t>CI</a:t>
-                      </a:r>
-                    </a:p>
-                  </a:txBody>
-                  <a:tcPr marL="76200" marR="76200" marT="50800" marB="50800">
-                    <a:solidFill>
-                      <a:srgbClr val="FFFFFF"/>
-                    </a:solidFill>
-                    <a:tcBdr>
-                      <a:bottom w="12700" cap="flat" cmpd="sng" algn="ctr">
-                        <a:solidFill>
-                          <a:srgbClr val="D1D9E6"/>
-                        </a:solidFill>
-                      </a:bottom>
-                    </a:tcBdr>
-                  </a:tcPr>
-                </a:tc>
-                <a:tc>
-                  <a:txBody>
-                    <a:bodyPr anchor="ctr"/>
-                    <a:lstStyle/>
-                    <a:p>
-                      <a:pPr algn="r" a:rtl="1"/>
-                      <a:r>
-                        <a:rPr sz="1200" b="0">
-                          <a:solidFill>
-                            <a:srgbClr val="2D343E"/>
-                          </a:solidFill>
-                          <a:latin typeface="Tahoma"/>
-                        </a:rPr>
-                        <a:t>CI = (λmax − n) / (n − 1)</a:t>
-                      </a:r>
-                    </a:p>
-                  </a:txBody>
-                  <a:tcPr marL="76200" marR="76200" marT="50800" marB="50800">
-                    <a:solidFill>
-                      <a:srgbClr val="FFFFFF"/>
-                    </a:solidFill>
-                    <a:tcBdr>
-                      <a:bottom w="12700" cap="flat" cmpd="sng" algn="ctr">
-                        <a:solidFill>
-                          <a:srgbClr val="D1D9E6"/>
-                        </a:solidFill>
-                      </a:bottom>
-                    </a:tcBdr>
-                  </a:tcPr>
-                </a:tc>
-              </a:tr>
-              <a:tr h="437605">
-                <a:tc>
-                  <a:txBody>
-                    <a:bodyPr anchor="ctr"/>
-                    <a:lstStyle/>
-                    <a:p>
-                      <a:pPr algn="r" a:rtl="1"/>
-                      <a:r>
-                        <a:rPr sz="1200" b="0">
-                          <a:solidFill>
-                            <a:srgbClr val="2D343E"/>
-                          </a:solidFill>
-                          <a:latin typeface="Tahoma"/>
-                        </a:rPr>
-                        <a:t>شاخص تصادفی</a:t>
-                      </a:r>
-                    </a:p>
-                  </a:txBody>
-                  <a:tcPr marL="76200" marR="76200" marT="50800" marB="50800">
-                    <a:solidFill>
-                      <a:srgbClr val="F0F4F8"/>
-                    </a:solidFill>
-                    <a:tcBdr>
-                      <a:bottom w="12700" cap="flat" cmpd="sng" algn="ctr">
-                        <a:solidFill>
-                          <a:srgbClr val="D1D9E6"/>
-                        </a:solidFill>
-                      </a:bottom>
-                    </a:tcBdr>
-                  </a:tcPr>
-                </a:tc>
-                <a:tc>
-                  <a:txBody>
-                    <a:bodyPr anchor="ctr"/>
-                    <a:lstStyle/>
-                    <a:p>
-                      <a:pPr algn="ctr" a:rtl="1"/>
-                      <a:r>
-                        <a:rPr sz="1200" b="1">
-                          <a:solidFill>
-                            <a:srgbClr val="2D343E"/>
-                          </a:solidFill>
-                          <a:latin typeface="Tahoma"/>
-                        </a:rPr>
-                        <a:t>RI</a:t>
-                      </a:r>
-                    </a:p>
-                  </a:txBody>
-                  <a:tcPr marL="76200" marR="76200" marT="50800" marB="50800">
-                    <a:solidFill>
-                      <a:srgbClr val="F0F4F8"/>
-                    </a:solidFill>
-                    <a:tcBdr>
-                      <a:bottom w="12700" cap="flat" cmpd="sng" algn="ctr">
-                        <a:solidFill>
-                          <a:srgbClr val="D1D9E6"/>
-                        </a:solidFill>
-                      </a:bottom>
-                    </a:tcBdr>
-                  </a:tcPr>
-                </a:tc>
-                <a:tc>
-                  <a:txBody>
-                    <a:bodyPr anchor="ctr"/>
-                    <a:lstStyle/>
-                    <a:p>
-                      <a:pPr algn="r" a:rtl="1"/>
-                      <a:r>
-                        <a:rPr sz="1200" b="0">
-                          <a:solidFill>
-                            <a:srgbClr val="2D343E"/>
-                          </a:solidFill>
-                          <a:latin typeface="Tahoma"/>
-                        </a:rPr>
-                        <a:t>طبق جدول ساعتی (Saaty)</a:t>
-                      </a:r>
-                    </a:p>
-                  </a:txBody>
-                  <a:tcPr marL="76200" marR="76200" marT="50800" marB="50800">
-                    <a:solidFill>
-                      <a:srgbClr val="F0F4F8"/>
-                    </a:solidFill>
-                    <a:tcBdr>
-                      <a:bottom w="12700" cap="flat" cmpd="sng" algn="ctr">
-                        <a:solidFill>
-                          <a:srgbClr val="D1D9E6"/>
-                        </a:solidFill>
-                      </a:bottom>
-                    </a:tcBdr>
-                  </a:tcPr>
-                </a:tc>
-              </a:tr>
-              <a:tr h="437605">
-                <a:tc>
-                  <a:txBody>
-                    <a:bodyPr anchor="ctr"/>
-                    <a:lstStyle/>
-                    <a:p>
-                      <a:pPr algn="r" a:rtl="1"/>
-                      <a:r>
-                        <a:rPr sz="1200" b="1">
-                          <a:solidFill>
-                            <a:srgbClr val="2D343E"/>
-                          </a:solidFill>
-                          <a:latin typeface="Tahoma"/>
-                        </a:rPr>
-                        <a:t>نرخ سازگاری</a:t>
-                      </a:r>
-                    </a:p>
-                  </a:txBody>
-                  <a:tcPr marL="76200" marR="76200" marT="50800" marB="50800">
-                    <a:solidFill>
-                      <a:srgbClr val="FFFFFF"/>
-                    </a:solidFill>
-                    <a:tcBdr>
-                      <a:bottom w="12700" cap="flat" cmpd="sng" algn="ctr">
-                        <a:solidFill>
-                          <a:srgbClr val="D1D9E6"/>
-                        </a:solidFill>
-                      </a:bottom>
-                    </a:tcBdr>
-                  </a:tcPr>
-                </a:tc>
-                <a:tc>
-                  <a:txBody>
-                    <a:bodyPr anchor="ctr"/>
-                    <a:lstStyle/>
-                    <a:p>
-                      <a:pPr algn="ctr" a:rtl="1"/>
-                      <a:r>
-                        <a:rPr sz="1200" b="1">
-                          <a:solidFill>
-                            <a:srgbClr val="1E3A5F"/>
-                          </a:solidFill>
-                          <a:latin typeface="Tahoma"/>
-                        </a:rPr>
-                        <a:t>CR</a:t>
-                      </a:r>
-                    </a:p>
-                  </a:txBody>
-                  <a:tcPr marL="76200" marR="76200" marT="50800" marB="50800">
-                    <a:solidFill>
-                      <a:srgbClr val="FFFFFF"/>
-                    </a:solidFill>
-                    <a:tcBdr>
-                      <a:bottom w="12700" cap="flat" cmpd="sng" algn="ctr">
-                        <a:solidFill>
-                          <a:srgbClr val="D1D9E6"/>
-                        </a:solidFill>
-                      </a:bottom>
-                    </a:tcBdr>
-                  </a:tcPr>
-                </a:tc>
-                <a:tc>
-                  <a:txBody>
-                    <a:bodyPr anchor="ctr"/>
-                    <a:lstStyle/>
-                    <a:p>
-                      <a:pPr algn="r" a:rtl="1"/>
-                      <a:r>
-                        <a:rPr sz="1200" b="0">
-                          <a:solidFill>
-                            <a:srgbClr val="2D343E"/>
-                          </a:solidFill>
-                          <a:latin typeface="Tahoma"/>
-                        </a:rPr>
-                        <a:t>CR = CI / RI</a:t>
-                      </a:r>
-                    </a:p>
-                  </a:txBody>
-                  <a:tcPr marL="76200" marR="76200" marT="50800" marB="50800">
-                    <a:solidFill>
-                      <a:srgbClr val="FFFFFF"/>
-                    </a:solidFill>
-                    <a:tcBdr>
-                      <a:bottom w="12700" cap="flat" cmpd="sng" algn="ctr">
-                        <a:solidFill>
-                          <a:srgbClr val="D1D9E6"/>
-                        </a:solidFill>
-                      </a:bottom>
-                    </a:tcBdr>
-                  </a:tcPr>
-                </a:tc>
-              </a:tr>
-              <a:tr h="437610">
-                <a:tc>
-                  <a:txBody>
-                    <a:bodyPr anchor="ctr"/>
-                    <a:lstStyle/>
-                    <a:p>
-                      <a:pPr algn="r" a:rtl="1"/>
-                      <a:r>
-                        <a:rPr sz="1200" b="1">
-                          <a:solidFill>
-                            <a:srgbClr val="1B5E20"/>
-                          </a:solidFill>
-                          <a:latin typeface="Tahoma"/>
-                        </a:rPr>
-                        <a:t>آستانه قابل قبول</a:t>
-                      </a:r>
-                    </a:p>
-                  </a:txBody>
-                  <a:tcPr marL="76200" marR="76200" marT="50800" marB="50800">
-                    <a:solidFill>
-                      <a:srgbClr val="E8F5E9"/>
-                    </a:solidFill>
-                    <a:tcBdr>
-                      <a:bottom w="12700" cap="flat" cmpd="sng" algn="ctr">
-                        <a:solidFill>
-                          <a:srgbClr val="D1D9E6"/>
-                        </a:solidFill>
-                      </a:bottom>
-                    </a:tcBdr>
-                  </a:tcPr>
-                </a:tc>
-                <a:tc>
-                  <a:txBody>
-                    <a:bodyPr anchor="ctr"/>
-                    <a:lstStyle/>
-                    <a:p>
-                      <a:pPr algn="ctr" a:rtl="1"/>
-                      <a:r>
-                        <a:rPr sz="1200" b="1">
-                          <a:solidFill>
-                            <a:srgbClr val="2D343E"/>
-                          </a:solidFill>
-                          <a:latin typeface="Tahoma"/>
-                        </a:rPr>
-                        <a:t>—</a:t>
-                      </a:r>
-                    </a:p>
-                  </a:txBody>
-                  <a:tcPr marL="76200" marR="76200" marT="50800" marB="50800">
-                    <a:solidFill>
-                      <a:srgbClr val="E8F5E9"/>
-                    </a:solidFill>
-                    <a:tcBdr>
-                      <a:bottom w="12700" cap="flat" cmpd="sng" algn="ctr">
-                        <a:solidFill>
-                          <a:srgbClr val="D1D9E6"/>
-                        </a:solidFill>
-                      </a:bottom>
-                    </a:tcBdr>
-                  </a:tcPr>
-                </a:tc>
-                <a:tc>
-                  <a:txBody>
-                    <a:bodyPr anchor="ctr"/>
-                    <a:lstStyle/>
-                    <a:p>
-                      <a:pPr algn="r" a:rtl="1"/>
-                      <a:r>
-                        <a:rPr sz="1200" b="0">
-                          <a:solidFill>
-                            <a:srgbClr val="1B5E20"/>
-                          </a:solidFill>
-                          <a:latin typeface="Tahoma"/>
-                        </a:rPr>
-                        <a:t>کمتر از ۰٫۱</a:t>
-                      </a:r>
-                    </a:p>
-                  </a:txBody>
-                  <a:tcPr marL="76200" marR="76200" marT="50800" marB="50800">
-                    <a:solidFill>
-                      <a:srgbClr val="E8F5E9"/>
-                    </a:solidFill>
-                    <a:tcBdr>
-                      <a:bottom w="12700" cap="flat" cmpd="sng" algn="ctr">
-                        <a:solidFill>
-                          <a:srgbClr val="D1D9E6"/>
-                        </a:solidFill>
-                      </a:bottom>
-                    </a:tcBdr>
-                  </a:tcPr>
-                </a:tc>
-              </a:tr>
-            </a:tbl>
-          </a:graphicData>
-        </a:graphic>
-      </p:graphicFrame>
-      <p:sp>
-        <p:nvSpPr>
-          <p:cNvPr id="9" name="Rounded Rectangle 8"/>
+              <a:t>CR &lt; 0.1</a:t>
+            </a:r>
+          </a:p>
+        </p:txBody>
+      </p:sp>
+      <p:sp>
+        <p:nvSpPr>
+          <p:cNvPr id="35" name="Rounded Rectangle 34"/>
           <p:cNvSpPr/>
           <p:nvPr/>
         </p:nvSpPr>
         <p:spPr>
           <a:xfrm>
-            <a:off x="6720840" y="1417320"/>
-            <a:ext cx="2148840" cy="3063240"/>
+            <a:off x="6675120" y="2468880"/>
+            <a:ext cx="1737360" cy="502920"/>
           </a:xfrm>
           <a:prstGeom prst="roundRect">
-            <a:avLst/>
+            <a:avLst>
+              <a:gd name="adj" fmla="val 10000"/>
+            </a:avLst>
           </a:prstGeom>
           <a:solidFill>
-            <a:srgbClr val="FFFFFF"/>
+            <a:srgbClr val="F0FDF4"/>
           </a:solidFill>
-          <a:ln w="12700">
+          <a:ln w="19050">
             <a:solidFill>
-              <a:srgbClr val="D1D9E6"/>
+              <a:srgbClr val="16A334"/>
             </a:solidFill>
           </a:ln>
         </p:spPr>
@@ -4077,14 +4484,14 @@
       </p:sp>
       <p:sp>
         <p:nvSpPr>
-          <p:cNvPr id="10" name="TextBox 9"/>
+          <p:cNvPr id="36" name="TextBox 35"/>
           <p:cNvSpPr txBox="1"/>
           <p:nvPr/>
         </p:nvSpPr>
         <p:spPr>
           <a:xfrm>
-            <a:off x="6903720" y="1600200"/>
-            <a:ext cx="1783080" cy="320040"/>
+            <a:off x="6675120" y="2587752"/>
+            <a:ext cx="1737360" cy="274320"/>
           </a:xfrm>
           <a:prstGeom prst="rect">
             <a:avLst/>
@@ -4099,37 +4506,39 @@
           <a:p>
             <a:pPr algn="ctr" a:rtl="1"/>
             <a:r>
-              <a:rPr sz="1500" b="1">
+              <a:rPr sz="1200" b="1">
                 <a:solidFill>
-                  <a:srgbClr val="1E3A5F"/>
+                  <a:srgbClr val="15803D"/>
                 </a:solidFill>
                 <a:latin typeface="Tahoma"/>
               </a:rPr>
-              <a:t>معیار پذیرش</a:t>
-            </a:r>
-          </a:p>
-        </p:txBody>
-      </p:sp>
-      <p:sp>
-        <p:nvSpPr>
-          <p:cNvPr id="11" name="Rounded Rectangle 10"/>
+              <a:t>✓  قابل قبول</a:t>
+            </a:r>
+          </a:p>
+        </p:txBody>
+      </p:sp>
+      <p:sp>
+        <p:nvSpPr>
+          <p:cNvPr id="37" name="Rounded Rectangle 36"/>
           <p:cNvSpPr/>
           <p:nvPr/>
         </p:nvSpPr>
         <p:spPr>
           <a:xfrm>
-            <a:off x="6903720" y="2057400"/>
-            <a:ext cx="1783080" cy="868680"/>
+            <a:off x="6675120" y="3063240"/>
+            <a:ext cx="1737360" cy="502920"/>
           </a:xfrm>
           <a:prstGeom prst="roundRect">
-            <a:avLst/>
+            <a:avLst>
+              <a:gd name="adj" fmla="val 10000"/>
+            </a:avLst>
           </a:prstGeom>
           <a:solidFill>
-            <a:srgbClr val="E8F5E9"/>
+            <a:srgbClr val="FEF2F2"/>
           </a:solidFill>
-          <a:ln w="12700">
+          <a:ln w="19050">
             <a:solidFill>
-              <a:srgbClr val="2E7D32"/>
+              <a:srgbClr val="DC2626"/>
             </a:solidFill>
           </a:ln>
         </p:spPr>
@@ -4157,14 +4566,14 @@
       </p:sp>
       <p:sp>
         <p:nvSpPr>
-          <p:cNvPr id="12" name="TextBox 11"/>
+          <p:cNvPr id="38" name="TextBox 37"/>
           <p:cNvSpPr txBox="1"/>
           <p:nvPr/>
         </p:nvSpPr>
         <p:spPr>
           <a:xfrm>
-            <a:off x="6995160" y="2176272"/>
-            <a:ext cx="1600200" cy="274320"/>
+            <a:off x="6675120" y="3182112"/>
+            <a:ext cx="1737360" cy="274320"/>
           </a:xfrm>
           <a:prstGeom prst="rect">
             <a:avLst/>
@@ -4177,29 +4586,29 @@
           </a:bodyPr>
           <a:lstStyle/>
           <a:p>
-            <a:pPr algn="ctr"/>
-            <a:r>
-              <a:rPr sz="1400" b="1">
+            <a:pPr algn="ctr" a:rtl="1"/>
+            <a:r>
+              <a:rPr sz="1200" b="1">
                 <a:solidFill>
-                  <a:srgbClr val="1B5E20"/>
+                  <a:srgbClr val="DC2626"/>
                 </a:solidFill>
                 <a:latin typeface="Tahoma"/>
               </a:rPr>
-              <a:t>CR &lt; 0.1</a:t>
-            </a:r>
-          </a:p>
-        </p:txBody>
-      </p:sp>
-      <p:sp>
-        <p:nvSpPr>
-          <p:cNvPr id="13" name="TextBox 12"/>
+              <a:t>✗  نیاز به بازنگری</a:t>
+            </a:r>
+          </a:p>
+        </p:txBody>
+      </p:sp>
+      <p:sp>
+        <p:nvSpPr>
+          <p:cNvPr id="39" name="TextBox 38"/>
           <p:cNvSpPr txBox="1"/>
           <p:nvPr/>
         </p:nvSpPr>
         <p:spPr>
           <a:xfrm>
-            <a:off x="6995160" y="2487168"/>
-            <a:ext cx="1600200" cy="274320"/>
+            <a:off x="6629400" y="3703320"/>
+            <a:ext cx="1828800" cy="411480"/>
           </a:xfrm>
           <a:prstGeom prst="rect">
             <a:avLst/>
@@ -4214,37 +4623,72 @@
           <a:p>
             <a:pPr algn="ctr" a:rtl="1"/>
             <a:r>
-              <a:rPr sz="1300" b="1">
+              <a:rPr sz="850" b="0">
                 <a:solidFill>
-                  <a:srgbClr val="2E7D32"/>
+                  <a:srgbClr val="64748B"/>
                 </a:solidFill>
                 <a:latin typeface="Tahoma"/>
               </a:rPr>
-              <a:t>✓  قابل قبول</a:t>
-            </a:r>
-          </a:p>
-        </p:txBody>
-      </p:sp>
-      <p:sp>
-        <p:nvSpPr>
-          <p:cNvPr id="14" name="Rounded Rectangle 13"/>
+              <a:t>در صورت عدم سازگاری، مقایسه‌های زوجی بازبینی می‌شوند.</a:t>
+            </a:r>
+          </a:p>
+        </p:txBody>
+      </p:sp>
+      <p:sp>
+        <p:nvSpPr>
+          <p:cNvPr id="40" name="TextBox 39"/>
+          <p:cNvSpPr txBox="1"/>
+          <p:nvPr/>
+        </p:nvSpPr>
+        <p:spPr>
+          <a:xfrm>
+            <a:off x="457200" y="3977639"/>
+            <a:ext cx="8092440" cy="228600"/>
+          </a:xfrm>
+          <a:prstGeom prst="rect">
+            <a:avLst/>
+          </a:prstGeom>
+          <a:noFill/>
+        </p:spPr>
+        <p:txBody>
+          <a:bodyPr wrap="square" anchor="ctr">
+            <a:spAutoFit/>
+          </a:bodyPr>
+          <a:lstStyle/>
+          <a:p>
+            <a:pPr algn="r" a:rtl="1"/>
+            <a:r>
+              <a:rPr sz="1000" b="1">
+                <a:solidFill>
+                  <a:srgbClr val="1E293B"/>
+                </a:solidFill>
+                <a:latin typeface="Tahoma"/>
+              </a:rPr>
+              <a:t>مقیاس نرخ سازگاری</a:t>
+            </a:r>
+          </a:p>
+        </p:txBody>
+      </p:sp>
+      <p:sp>
+        <p:nvSpPr>
+          <p:cNvPr id="41" name="Rounded Rectangle 40"/>
           <p:cNvSpPr/>
           <p:nvPr/>
         </p:nvSpPr>
         <p:spPr>
           <a:xfrm>
-            <a:off x="6903720" y="3063240"/>
-            <a:ext cx="1783080" cy="868680"/>
+            <a:off x="457200" y="4251959"/>
+            <a:ext cx="2832354" cy="164592"/>
           </a:xfrm>
           <a:prstGeom prst="roundRect">
             <a:avLst/>
           </a:prstGeom>
           <a:solidFill>
-            <a:srgbClr val="FFEBEE"/>
+            <a:srgbClr val="F0FDF4"/>
           </a:solidFill>
           <a:ln w="12700">
             <a:solidFill>
-              <a:srgbClr val="C62828"/>
+              <a:srgbClr val="16A334"/>
             </a:solidFill>
           </a:ln>
         </p:spPr>
@@ -4272,14 +4716,102 @@
       </p:sp>
       <p:sp>
         <p:nvSpPr>
-          <p:cNvPr id="15" name="TextBox 14"/>
+          <p:cNvPr id="42" name="Rounded Rectangle 41"/>
+          <p:cNvSpPr/>
+          <p:nvPr/>
+        </p:nvSpPr>
+        <p:spPr>
+          <a:xfrm>
+            <a:off x="3289554" y="4251959"/>
+            <a:ext cx="5260086" cy="164592"/>
+          </a:xfrm>
+          <a:prstGeom prst="roundRect">
+            <a:avLst/>
+          </a:prstGeom>
+          <a:solidFill>
+            <a:srgbClr val="FEF2F2"/>
+          </a:solidFill>
+          <a:ln w="12700">
+            <a:solidFill>
+              <a:srgbClr val="DC2626"/>
+            </a:solidFill>
+          </a:ln>
+        </p:spPr>
+        <p:style>
+          <a:lnRef idx="1">
+            <a:schemeClr val="accent1"/>
+          </a:lnRef>
+          <a:fillRef idx="3">
+            <a:schemeClr val="accent1"/>
+          </a:fillRef>
+          <a:effectRef idx="2">
+            <a:schemeClr val="accent1"/>
+          </a:effectRef>
+          <a:fontRef idx="minor">
+            <a:schemeClr val="lt1"/>
+          </a:fontRef>
+        </p:style>
+        <p:txBody>
+          <a:bodyPr rtlCol="0" anchor="ctr"/>
+          <a:lstStyle/>
+          <a:p>
+            <a:pPr algn="ctr"/>
+          </a:p>
+        </p:txBody>
+      </p:sp>
+      <p:sp>
+        <p:nvSpPr>
+          <p:cNvPr id="43" name="Rectangle 42"/>
+          <p:cNvSpPr/>
+          <p:nvPr/>
+        </p:nvSpPr>
+        <p:spPr>
+          <a:xfrm>
+            <a:off x="3270504" y="4215383"/>
+            <a:ext cx="38100" cy="237744"/>
+          </a:xfrm>
+          <a:prstGeom prst="rect">
+            <a:avLst/>
+          </a:prstGeom>
+          <a:solidFill>
+            <a:srgbClr val="1D4ED8"/>
+          </a:solidFill>
+          <a:ln>
+            <a:noFill/>
+          </a:ln>
+        </p:spPr>
+        <p:style>
+          <a:lnRef idx="1">
+            <a:schemeClr val="accent1"/>
+          </a:lnRef>
+          <a:fillRef idx="3">
+            <a:schemeClr val="accent1"/>
+          </a:fillRef>
+          <a:effectRef idx="2">
+            <a:schemeClr val="accent1"/>
+          </a:effectRef>
+          <a:fontRef idx="minor">
+            <a:schemeClr val="lt1"/>
+          </a:fontRef>
+        </p:style>
+        <p:txBody>
+          <a:bodyPr rtlCol="0" anchor="ctr"/>
+          <a:lstStyle/>
+          <a:p>
+            <a:pPr algn="ctr"/>
+          </a:p>
+        </p:txBody>
+      </p:sp>
+      <p:sp>
+        <p:nvSpPr>
+          <p:cNvPr id="44" name="TextBox 43"/>
           <p:cNvSpPr txBox="1"/>
           <p:nvPr/>
         </p:nvSpPr>
         <p:spPr>
           <a:xfrm>
-            <a:off x="6995160" y="3182112"/>
-            <a:ext cx="1600200" cy="274320"/>
+            <a:off x="457200" y="4453127"/>
+            <a:ext cx="2832354" cy="201168"/>
           </a:xfrm>
           <a:prstGeom prst="rect">
             <a:avLst/>
@@ -4292,29 +4824,29 @@
           </a:bodyPr>
           <a:lstStyle/>
           <a:p>
-            <a:pPr algn="ctr"/>
-            <a:r>
-              <a:rPr sz="1400" b="1">
+            <a:pPr algn="ctr" a:rtl="1"/>
+            <a:r>
+              <a:rPr sz="800" b="0">
                 <a:solidFill>
-                  <a:srgbClr val="C62828"/>
+                  <a:srgbClr val="15803D"/>
                 </a:solidFill>
                 <a:latin typeface="Tahoma"/>
               </a:rPr>
-              <a:t>CR ≥ 0.1</a:t>
-            </a:r>
-          </a:p>
-        </p:txBody>
-      </p:sp>
-      <p:sp>
-        <p:nvSpPr>
-          <p:cNvPr id="16" name="TextBox 15"/>
+              <a:t>قابل قبول</a:t>
+            </a:r>
+          </a:p>
+        </p:txBody>
+      </p:sp>
+      <p:sp>
+        <p:nvSpPr>
+          <p:cNvPr id="45" name="TextBox 44"/>
           <p:cNvSpPr txBox="1"/>
           <p:nvPr/>
         </p:nvSpPr>
         <p:spPr>
           <a:xfrm>
-            <a:off x="6995160" y="3493008"/>
-            <a:ext cx="1600200" cy="274320"/>
+            <a:off x="3289554" y="4453127"/>
+            <a:ext cx="5260086" cy="201168"/>
           </a:xfrm>
           <a:prstGeom prst="rect">
             <a:avLst/>
@@ -4329,27 +4861,27 @@
           <a:p>
             <a:pPr algn="ctr" a:rtl="1"/>
             <a:r>
-              <a:rPr sz="1300" b="1">
+              <a:rPr sz="800" b="0">
                 <a:solidFill>
-                  <a:srgbClr val="C62828"/>
+                  <a:srgbClr val="DC2626"/>
                 </a:solidFill>
                 <a:latin typeface="Tahoma"/>
               </a:rPr>
-              <a:t>✗  نیاز به بازنگری</a:t>
-            </a:r>
-          </a:p>
-        </p:txBody>
-      </p:sp>
-      <p:sp>
-        <p:nvSpPr>
-          <p:cNvPr id="17" name="TextBox 16"/>
+              <a:t>بازنگری</a:t>
+            </a:r>
+          </a:p>
+        </p:txBody>
+      </p:sp>
+      <p:sp>
+        <p:nvSpPr>
+          <p:cNvPr id="46" name="TextBox 45"/>
           <p:cNvSpPr txBox="1"/>
           <p:nvPr/>
         </p:nvSpPr>
         <p:spPr>
           <a:xfrm>
-            <a:off x="6903720" y="4069080"/>
-            <a:ext cx="1783080" cy="502920"/>
+            <a:off x="3060954" y="4453127"/>
+            <a:ext cx="457200" cy="201168"/>
           </a:xfrm>
           <a:prstGeom prst="rect">
             <a:avLst/>
@@ -4362,29 +4894,29 @@
           </a:bodyPr>
           <a:lstStyle/>
           <a:p>
-            <a:pPr algn="ctr" a:rtl="1"/>
-            <a:r>
-              <a:rPr sz="1000" b="0">
+            <a:pPr algn="ctr"/>
+            <a:r>
+              <a:rPr sz="800" b="1">
                 <a:solidFill>
-                  <a:srgbClr val="6B7280"/>
+                  <a:srgbClr val="1D4ED8"/>
                 </a:solidFill>
                 <a:latin typeface="Tahoma"/>
               </a:rPr>
-              <a:t>در صورت عدم سازگاری، مقایسه‌های زوجی بازبینی شوند.</a:t>
-            </a:r>
-          </a:p>
-        </p:txBody>
-      </p:sp>
-      <p:sp>
-        <p:nvSpPr>
-          <p:cNvPr id="18" name="TextBox 17"/>
+              <a:t>0.1</a:t>
+            </a:r>
+          </a:p>
+        </p:txBody>
+      </p:sp>
+      <p:sp>
+        <p:nvSpPr>
+          <p:cNvPr id="47" name="TextBox 46"/>
           <p:cNvSpPr txBox="1"/>
           <p:nvPr/>
         </p:nvSpPr>
         <p:spPr>
           <a:xfrm>
-            <a:off x="502920" y="4617720"/>
-            <a:ext cx="8366760" cy="274320"/>
+            <a:off x="457200" y="4087367"/>
+            <a:ext cx="274320" cy="164592"/>
           </a:xfrm>
           <a:prstGeom prst="rect">
             <a:avLst/>
@@ -4397,15 +4929,171 @@
           </a:bodyPr>
           <a:lstStyle/>
           <a:p>
-            <a:pPr algn="l"/>
-            <a:r>
-              <a:rPr sz="1000" b="0">
+            <a:pPr algn="ctr"/>
+            <a:r>
+              <a:rPr sz="800" b="0">
                 <a:solidFill>
-                  <a:srgbClr val="6B7280"/>
+                  <a:srgbClr val="64748B"/>
                 </a:solidFill>
                 <a:latin typeface="Tahoma"/>
               </a:rPr>
-              <a:t>روش تحلیل سلسله‌مراتبی (AHP) — Saaty</a:t>
+              <a:t>0</a:t>
+            </a:r>
+          </a:p>
+        </p:txBody>
+      </p:sp>
+      <p:sp>
+        <p:nvSpPr>
+          <p:cNvPr id="48" name="TextBox 47"/>
+          <p:cNvSpPr txBox="1"/>
+          <p:nvPr/>
+        </p:nvSpPr>
+        <p:spPr>
+          <a:xfrm>
+            <a:off x="457200" y="4462272"/>
+            <a:ext cx="1828800" cy="274320"/>
+          </a:xfrm>
+          <a:prstGeom prst="rect">
+            <a:avLst/>
+          </a:prstGeom>
+          <a:noFill/>
+        </p:spPr>
+        <p:txBody>
+          <a:bodyPr wrap="square" anchor="ctr">
+            <a:spAutoFit/>
+          </a:bodyPr>
+          <a:lstStyle/>
+          <a:p>
+            <a:pPr algn="r" a:rtl="1"/>
+            <a:r>
+              <a:rPr sz="1100" b="1">
+                <a:solidFill>
+                  <a:srgbClr val="2563EB"/>
+                </a:solidFill>
+                <a:latin typeface="Tahoma"/>
+              </a:rPr>
+              <a:t>روش پیشنهادی</a:t>
+            </a:r>
+          </a:p>
+        </p:txBody>
+      </p:sp>
+      <p:sp>
+        <p:nvSpPr>
+          <p:cNvPr id="49" name="Oval 48"/>
+          <p:cNvSpPr/>
+          <p:nvPr/>
+        </p:nvSpPr>
+        <p:spPr>
+          <a:xfrm>
+            <a:off x="2743200" y="4480560"/>
+            <a:ext cx="256032" cy="256032"/>
+          </a:xfrm>
+          <a:prstGeom prst="ellipse">
+            <a:avLst/>
+          </a:prstGeom>
+          <a:solidFill>
+            <a:srgbClr val="2563EB"/>
+          </a:solidFill>
+          <a:ln>
+            <a:noFill/>
+          </a:ln>
+        </p:spPr>
+        <p:style>
+          <a:lnRef idx="1">
+            <a:schemeClr val="accent1"/>
+          </a:lnRef>
+          <a:fillRef idx="3">
+            <a:schemeClr val="accent1"/>
+          </a:fillRef>
+          <a:effectRef idx="2">
+            <a:schemeClr val="accent1"/>
+          </a:effectRef>
+          <a:fontRef idx="minor">
+            <a:schemeClr val="lt1"/>
+          </a:fontRef>
+        </p:style>
+        <p:txBody>
+          <a:bodyPr rtlCol="0" anchor="ctr"/>
+          <a:lstStyle/>
+          <a:p>
+            <a:pPr algn="ctr"/>
+          </a:p>
+        </p:txBody>
+      </p:sp>
+      <p:sp>
+        <p:nvSpPr>
+          <p:cNvPr id="50" name="Oval 49"/>
+          <p:cNvSpPr/>
+          <p:nvPr/>
+        </p:nvSpPr>
+        <p:spPr>
+          <a:xfrm>
+            <a:off x="3429000" y="4480560"/>
+            <a:ext cx="256032" cy="256032"/>
+          </a:xfrm>
+          <a:prstGeom prst="ellipse">
+            <a:avLst/>
+          </a:prstGeom>
+          <a:solidFill>
+            <a:srgbClr val="2563EB"/>
+          </a:solidFill>
+          <a:ln>
+            <a:noFill/>
+          </a:ln>
+        </p:spPr>
+        <p:style>
+          <a:lnRef idx="1">
+            <a:schemeClr val="accent1"/>
+          </a:lnRef>
+          <a:fillRef idx="3">
+            <a:schemeClr val="accent1"/>
+          </a:fillRef>
+          <a:effectRef idx="2">
+            <a:schemeClr val="accent1"/>
+          </a:effectRef>
+          <a:fontRef idx="minor">
+            <a:schemeClr val="lt1"/>
+          </a:fontRef>
+        </p:style>
+        <p:txBody>
+          <a:bodyPr rtlCol="0" anchor="ctr"/>
+          <a:lstStyle/>
+          <a:p>
+            <a:pPr algn="ctr"/>
+          </a:p>
+        </p:txBody>
+      </p:sp>
+      <p:sp>
+        <p:nvSpPr>
+          <p:cNvPr id="51" name="TextBox 50"/>
+          <p:cNvSpPr txBox="1"/>
+          <p:nvPr/>
+        </p:nvSpPr>
+        <p:spPr>
+          <a:xfrm>
+            <a:off x="3063240" y="4462272"/>
+            <a:ext cx="320040" cy="274320"/>
+          </a:xfrm>
+          <a:prstGeom prst="rect">
+            <a:avLst/>
+          </a:prstGeom>
+          <a:noFill/>
+        </p:spPr>
+        <p:txBody>
+          <a:bodyPr wrap="square" anchor="ctr">
+            <a:spAutoFit/>
+          </a:bodyPr>
+          <a:lstStyle/>
+          <a:p>
+            <a:pPr algn="ctr"/>
+            <a:r>
+              <a:rPr sz="1100" b="1">
+                <a:solidFill>
+                  <a:srgbClr val="1E293B"/>
+                </a:solidFill>
+                <a:latin typeface="Tahoma"/>
+              </a:rPr>
+              <a:t>25</a:t>
             </a:r>
           </a:p>
         </p:txBody>

</xml_diff>